<commit_message>
Pitch deck v2: 21 slides, references slide, updated sources
- Slide 21 added: References — full citations + methodology note
- Per-slide source lines tightened throughout
- Sources: Carers UK (Key Facts 2025, State of Caring 2024),
  AARP (Caregiving in US 2025, Valuing the Invaluable 2026),
  ScienceDirect caregiver-burnout meta-analysis 2025,
  Market Research Future Digital Mental Health Market 2025,
  MarketsandMarkets Mental Health Apps Market 2025
- HTML +6KB (867K), PPTX +31KB (571K), PDF regenerated (1.4MB)
- All 21 preview PNGs re-rendered at 1920x1080

Co-Authored-By: Claude Sonnet 4.6 <noreply@anthropic.com>
</commit_message>
<xml_diff>
--- a/slides/carer-pitch-deck.pptx
+++ b/slides/carer-pitch-deck.pptx
@@ -25,9 +25,10 @@
     <p:sldId id="273" r:id="rId19"/>
     <p:sldId id="274" r:id="rId20"/>
     <p:sldId id="275" r:id="rId21"/>
+    <p:sldId id="276" r:id="rId22"/>
   </p:sldIdLst>
   <p:notesMasterIdLst>
-    <p:notesMasterId r:id="rId22"/>
+    <p:notesMasterId r:id="rId23"/>
   </p:notesMasterIdLst>
   <p:sldSz cx="18288000" cy="10287000"/>
   <p:notesSz cx="10287000" cy="18288000"/>
@@ -1601,6 +1602,94 @@
             <a:fld id="{F7021451-1387-4CA6-816F-3879F97B5CBC}" type="slidenum">
               <a:rPr lang="en-US"/>
               <a:t>20</a:t>
+            </a:fld>
+            <a:endParaRPr lang="en-US"/>
+          </a:p>
+        </p:txBody>
+      </p:sp>
+    </p:spTree>
+    <p:extLst>
+      <p:ext uri="{BB962C8B-B14F-4D97-AF65-F5344CB8AC3E}">
+        <p14:creationId xmlns:p14="http://schemas.microsoft.com/office/powerpoint/2010/main" val="1024086991"/>
+      </p:ext>
+    </p:extLst>
+  </p:cSld>
+  <p:clrMapOvr>
+    <a:masterClrMapping/>
+  </p:clrMapOvr>
+</p:notes>
+</file>
+
+<file path=ppt/notesSlides/notesSlide21.xml><?xml version="1.0" encoding="utf-8"?>
+<p:notes xmlns:a="http://schemas.openxmlformats.org/drawingml/2006/main" xmlns:r="http://schemas.openxmlformats.org/officeDocument/2006/relationships" xmlns:p="http://schemas.openxmlformats.org/presentationml/2006/main">
+  <p:cSld>
+    <p:spTree>
+      <p:nvGrpSpPr>
+        <p:cNvPr id="1" name=""/>
+        <p:cNvGrpSpPr/>
+        <p:nvPr/>
+      </p:nvGrpSpPr>
+      <p:grpSpPr>
+        <a:xfrm>
+          <a:off x="0" y="0"/>
+          <a:ext cx="0" cy="0"/>
+          <a:chOff x="0" y="0"/>
+          <a:chExt cx="0" cy="0"/>
+        </a:xfrm>
+      </p:grpSpPr>
+      <p:sp>
+        <p:nvSpPr>
+          <p:cNvPr id="2" name="Slide Image Placeholder 1"/>
+          <p:cNvSpPr>
+            <a:spLocks noGrp="1" noRot="1" noChangeAspect="1"/>
+          </p:cNvSpPr>
+          <p:nvPr>
+            <p:ph type="sldImg"/>
+          </p:nvPr>
+        </p:nvSpPr>
+        <p:spPr/>
+      </p:sp>
+      <p:sp>
+        <p:nvSpPr>
+          <p:cNvPr id="3" name="Notes Placeholder 2"/>
+          <p:cNvSpPr>
+            <a:spLocks noGrp="1"/>
+          </p:cNvSpPr>
+          <p:nvPr>
+            <p:ph type="body" idx="1"/>
+          </p:nvPr>
+        </p:nvSpPr>
+        <p:spPr/>
+        <p:txBody>
+          <a:bodyPr/>
+          <a:lstStyle/>
+          <a:p>
+            <a:r>
+              <a:rPr lang="en-US" dirty="0"/>
+              <a:t>Every cited figure mapped to its source. Market figures are third-party estimates.</a:t>
+            </a:r>
+            <a:endParaRPr lang="en-US" dirty="0"/>
+          </a:p>
+        </p:txBody>
+      </p:sp>
+      <p:sp>
+        <p:nvSpPr>
+          <p:cNvPr id="4" name="Slide Number Placeholder 3"/>
+          <p:cNvSpPr>
+            <a:spLocks noGrp="1"/>
+          </p:cNvSpPr>
+          <p:nvPr>
+            <p:ph type="sldNum" sz="quarter" idx="10"/>
+          </p:nvPr>
+        </p:nvSpPr>
+        <p:spPr/>
+        <p:txBody>
+          <a:bodyPr/>
+          <a:lstStyle/>
+          <a:p>
+            <a:fld id="{F7021451-1387-4CA6-816F-3879F97B5CBC}" type="slidenum">
+              <a:rPr lang="en-US"/>
+              <a:t>21</a:t>
             </a:fld>
             <a:endParaRPr lang="en-US"/>
           </a:p>
@@ -4128,8 +4217,8 @@
         </p:nvSpPr>
         <p:spPr>
           <a:xfrm>
-            <a:off x="16486882" y="9510713"/>
-            <a:ext cx="924818" cy="319088"/>
+            <a:off x="16538079" y="9510713"/>
+            <a:ext cx="873621" cy="319088"/>
           </a:xfrm>
           <a:prstGeom prst="rect">
             <a:avLst/>
@@ -4155,7 +4244,7 @@
                 <a:ea typeface="Arial" pitchFamily="34" charset="-122"/>
                 <a:cs typeface="Arial" pitchFamily="34" charset="-120"/>
               </a:rPr>
-              <a:t>10 · 20</a:t>
+              <a:t>10 · 21</a:t>
             </a:r>
             <a:endParaRPr lang="en-US" sz="1800" dirty="0"/>
           </a:p>
@@ -4817,8 +4906,8 @@
         </p:nvSpPr>
         <p:spPr>
           <a:xfrm>
-            <a:off x="16538079" y="9510713"/>
-            <a:ext cx="873621" cy="319088"/>
+            <a:off x="16589350" y="9510713"/>
+            <a:ext cx="822350" cy="319088"/>
           </a:xfrm>
           <a:prstGeom prst="rect">
             <a:avLst/>
@@ -4844,7 +4933,7 @@
                 <a:ea typeface="Arial" pitchFamily="34" charset="-122"/>
                 <a:cs typeface="Arial" pitchFamily="34" charset="-120"/>
               </a:rPr>
-              <a:t>11 · 20</a:t>
+              <a:t>11 · 21</a:t>
             </a:r>
             <a:endParaRPr lang="en-US" sz="1800" dirty="0"/>
           </a:p>
@@ -5538,8 +5627,8 @@
         </p:nvSpPr>
         <p:spPr>
           <a:xfrm>
-            <a:off x="16491645" y="9510713"/>
-            <a:ext cx="920055" cy="319088"/>
+            <a:off x="16542916" y="9510713"/>
+            <a:ext cx="868784" cy="319088"/>
           </a:xfrm>
           <a:prstGeom prst="rect">
             <a:avLst/>
@@ -5565,7 +5654,7 @@
                 <a:ea typeface="Arial" pitchFamily="34" charset="-122"/>
                 <a:cs typeface="Arial" pitchFamily="34" charset="-120"/>
               </a:rPr>
-              <a:t>12 · 20</a:t>
+              <a:t>12 · 21</a:t>
             </a:r>
             <a:endParaRPr lang="en-US" sz="1800" dirty="0"/>
           </a:p>
@@ -5696,7 +5785,7 @@
         </p:nvSpPr>
         <p:spPr>
           <a:xfrm>
-            <a:off x="1133475" y="2326928"/>
+            <a:off x="1133475" y="2553146"/>
             <a:ext cx="5543550" cy="5543550"/>
           </a:xfrm>
           <a:prstGeom prst="ellipse">
@@ -5723,7 +5812,7 @@
         </p:nvSpPr>
         <p:spPr>
           <a:xfrm>
-            <a:off x="3629546" y="2974628"/>
+            <a:off x="3629546" y="3200846"/>
             <a:ext cx="627534" cy="647700"/>
           </a:xfrm>
           <a:prstGeom prst="rect">
@@ -5764,7 +5853,7 @@
         </p:nvSpPr>
         <p:spPr>
           <a:xfrm>
-            <a:off x="2085975" y="3584228"/>
+            <a:off x="2085975" y="3810446"/>
             <a:ext cx="3638550" cy="3638550"/>
           </a:xfrm>
           <a:prstGeom prst="ellipse">
@@ -5791,7 +5880,7 @@
         </p:nvSpPr>
         <p:spPr>
           <a:xfrm>
-            <a:off x="3614663" y="4250978"/>
+            <a:off x="3614663" y="4477196"/>
             <a:ext cx="657299" cy="533400"/>
           </a:xfrm>
           <a:prstGeom prst="rect">
@@ -5832,7 +5921,7 @@
         </p:nvSpPr>
         <p:spPr>
           <a:xfrm>
-            <a:off x="3000375" y="4746278"/>
+            <a:off x="3000375" y="4972496"/>
             <a:ext cx="1809750" cy="1809750"/>
           </a:xfrm>
           <a:prstGeom prst="ellipse">
@@ -5852,7 +5941,7 @@
         </p:nvSpPr>
         <p:spPr>
           <a:xfrm>
-            <a:off x="2962275" y="4746278"/>
+            <a:off x="2962275" y="4972496"/>
             <a:ext cx="1885950" cy="1847850"/>
           </a:xfrm>
           <a:prstGeom prst="rect">
@@ -5893,7 +5982,7 @@
         </p:nvSpPr>
         <p:spPr>
           <a:xfrm>
-            <a:off x="7524750" y="3955703"/>
+            <a:off x="7524750" y="3900934"/>
             <a:ext cx="9715500" cy="9525"/>
           </a:xfrm>
           <a:prstGeom prst="rect">
@@ -5913,7 +6002,7 @@
         </p:nvSpPr>
         <p:spPr>
           <a:xfrm>
-            <a:off x="7524750" y="2295971"/>
+            <a:off x="7524750" y="2241203"/>
             <a:ext cx="10687050" cy="300038"/>
           </a:xfrm>
           <a:prstGeom prst="rect">
@@ -5954,7 +6043,7 @@
         </p:nvSpPr>
         <p:spPr>
           <a:xfrm>
-            <a:off x="7524750" y="2653159"/>
+            <a:off x="7524750" y="2598390"/>
             <a:ext cx="10687050" cy="671513"/>
           </a:xfrm>
           <a:prstGeom prst="rect">
@@ -5995,7 +6084,7 @@
         </p:nvSpPr>
         <p:spPr>
           <a:xfrm>
-            <a:off x="7524750" y="3362771"/>
+            <a:off x="7524750" y="3308003"/>
             <a:ext cx="10687050" cy="383381"/>
           </a:xfrm>
           <a:prstGeom prst="rect">
@@ -6039,7 +6128,7 @@
         </p:nvSpPr>
         <p:spPr>
           <a:xfrm>
-            <a:off x="7524750" y="5910709"/>
+            <a:off x="7524750" y="5855940"/>
             <a:ext cx="9715500" cy="9525"/>
           </a:xfrm>
           <a:prstGeom prst="rect">
@@ -6059,7 +6148,7 @@
         </p:nvSpPr>
         <p:spPr>
           <a:xfrm>
-            <a:off x="7524750" y="4250978"/>
+            <a:off x="7524750" y="4196209"/>
             <a:ext cx="10687050" cy="300038"/>
           </a:xfrm>
           <a:prstGeom prst="rect">
@@ -6100,7 +6189,7 @@
         </p:nvSpPr>
         <p:spPr>
           <a:xfrm>
-            <a:off x="7524750" y="4608165"/>
+            <a:off x="7524750" y="4553396"/>
             <a:ext cx="10687050" cy="671513"/>
           </a:xfrm>
           <a:prstGeom prst="rect">
@@ -6141,7 +6230,7 @@
         </p:nvSpPr>
         <p:spPr>
           <a:xfrm>
-            <a:off x="7524750" y="5317778"/>
+            <a:off x="7524750" y="5263009"/>
             <a:ext cx="10687050" cy="383381"/>
           </a:xfrm>
           <a:prstGeom prst="rect">
@@ -6185,7 +6274,7 @@
         </p:nvSpPr>
         <p:spPr>
           <a:xfrm>
-            <a:off x="7524750" y="6205984"/>
+            <a:off x="7524750" y="6151215"/>
             <a:ext cx="10687050" cy="300038"/>
           </a:xfrm>
           <a:prstGeom prst="rect">
@@ -6226,7 +6315,7 @@
         </p:nvSpPr>
         <p:spPr>
           <a:xfrm>
-            <a:off x="7524750" y="6563171"/>
+            <a:off x="7524750" y="6508403"/>
             <a:ext cx="10006965" cy="809625"/>
           </a:xfrm>
           <a:prstGeom prst="rect">
@@ -6270,8 +6359,8 @@
         </p:nvSpPr>
         <p:spPr>
           <a:xfrm>
-            <a:off x="7524750" y="7620446"/>
-            <a:ext cx="10687050" cy="319088"/>
+            <a:off x="7524750" y="7565678"/>
+            <a:ext cx="10006965" cy="881063"/>
           </a:xfrm>
           <a:prstGeom prst="rect">
             <a:avLst/>
@@ -6297,7 +6386,7 @@
                 <a:ea typeface="Arial" pitchFamily="34" charset="-122"/>
                 <a:cs typeface="Arial" pitchFamily="34" charset="-120"/>
               </a:rPr>
-              <a:t>Sources: industry market reports 2025; Carers UK; AARP.</a:t>
+              <a:t>Sources: Market Research Future, Digital Mental Health Market (2025) · MarketsandMarkets, Mental Health Apps Market (2025) · Carers UK (2025) · AARP &amp; NAC (2025)</a:t>
             </a:r>
             <a:endParaRPr lang="en-US" sz="1800" dirty="0"/>
           </a:p>
@@ -6382,8 +6471,8 @@
         </p:nvSpPr>
         <p:spPr>
           <a:xfrm>
-            <a:off x="16489859" y="9510713"/>
-            <a:ext cx="921841" cy="319088"/>
+            <a:off x="16541130" y="9510713"/>
+            <a:ext cx="870570" cy="319088"/>
           </a:xfrm>
           <a:prstGeom prst="rect">
             <a:avLst/>
@@ -6409,7 +6498,7 @@
                 <a:ea typeface="Arial" pitchFamily="34" charset="-122"/>
                 <a:cs typeface="Arial" pitchFamily="34" charset="-120"/>
               </a:rPr>
-              <a:t>13 · 20</a:t>
+              <a:t>13 · 21</a:t>
             </a:r>
             <a:endParaRPr lang="en-US" sz="1800" dirty="0"/>
           </a:p>
@@ -7550,8 +7639,8 @@
         </p:nvSpPr>
         <p:spPr>
           <a:xfrm>
-            <a:off x="16483385" y="9510713"/>
-            <a:ext cx="928315" cy="319088"/>
+            <a:off x="16534656" y="9510713"/>
+            <a:ext cx="877044" cy="319088"/>
           </a:xfrm>
           <a:prstGeom prst="rect">
             <a:avLst/>
@@ -7577,7 +7666,7 @@
                 <a:ea typeface="Arial" pitchFamily="34" charset="-122"/>
                 <a:cs typeface="Arial" pitchFamily="34" charset="-120"/>
               </a:rPr>
-              <a:t>14 · 20</a:t>
+              <a:t>14 · 21</a:t>
             </a:r>
             <a:endParaRPr lang="en-US" sz="1800" dirty="0"/>
           </a:p>
@@ -8083,8 +8172,8 @@
         </p:nvSpPr>
         <p:spPr>
           <a:xfrm>
-            <a:off x="16495440" y="9510713"/>
-            <a:ext cx="916260" cy="319088"/>
+            <a:off x="16546711" y="9510713"/>
+            <a:ext cx="864989" cy="319088"/>
           </a:xfrm>
           <a:prstGeom prst="rect">
             <a:avLst/>
@@ -8110,7 +8199,7 @@
                 <a:ea typeface="Arial" pitchFamily="34" charset="-122"/>
                 <a:cs typeface="Arial" pitchFamily="34" charset="-120"/>
               </a:rPr>
-              <a:t>15 · 20</a:t>
+              <a:t>15 · 21</a:t>
             </a:r>
             <a:endParaRPr lang="en-US" sz="1800" dirty="0"/>
           </a:p>
@@ -9307,8 +9396,8 @@
         </p:nvSpPr>
         <p:spPr>
           <a:xfrm>
-            <a:off x="16489338" y="9510713"/>
-            <a:ext cx="922362" cy="319088"/>
+            <a:off x="16540535" y="9510713"/>
+            <a:ext cx="871165" cy="319088"/>
           </a:xfrm>
           <a:prstGeom prst="rect">
             <a:avLst/>
@@ -9334,7 +9423,7 @@
                 <a:ea typeface="Arial" pitchFamily="34" charset="-122"/>
                 <a:cs typeface="Arial" pitchFamily="34" charset="-120"/>
               </a:rPr>
-              <a:t>16 · 20</a:t>
+              <a:t>16 · 21</a:t>
             </a:r>
             <a:endParaRPr lang="en-US" sz="1800" dirty="0"/>
           </a:p>
@@ -10105,8 +10194,8 @@
         </p:nvSpPr>
         <p:spPr>
           <a:xfrm>
-            <a:off x="16501690" y="9510713"/>
-            <a:ext cx="910010" cy="319088"/>
+            <a:off x="16552962" y="9510713"/>
+            <a:ext cx="858738" cy="319088"/>
           </a:xfrm>
           <a:prstGeom prst="rect">
             <a:avLst/>
@@ -10132,7 +10221,7 @@
                 <a:ea typeface="Arial" pitchFamily="34" charset="-122"/>
                 <a:cs typeface="Arial" pitchFamily="34" charset="-120"/>
               </a:rPr>
-              <a:t>17 · 20</a:t>
+              <a:t>17 · 21</a:t>
             </a:r>
             <a:endParaRPr lang="en-US" sz="1800" dirty="0"/>
           </a:p>
@@ -10934,8 +11023,8 @@
         </p:nvSpPr>
         <p:spPr>
           <a:xfrm>
-            <a:off x="16489635" y="9510713"/>
-            <a:ext cx="922065" cy="319088"/>
+            <a:off x="16540907" y="9510713"/>
+            <a:ext cx="870793" cy="319088"/>
           </a:xfrm>
           <a:prstGeom prst="rect">
             <a:avLst/>
@@ -10961,7 +11050,7 @@
                 <a:ea typeface="Arial" pitchFamily="34" charset="-122"/>
                 <a:cs typeface="Arial" pitchFamily="34" charset="-120"/>
               </a:rPr>
-              <a:t>18 · 20</a:t>
+              <a:t>18 · 21</a:t>
             </a:r>
             <a:endParaRPr lang="en-US" sz="1800" dirty="0"/>
           </a:p>
@@ -11691,8 +11780,8 @@
         </p:nvSpPr>
         <p:spPr>
           <a:xfrm>
-            <a:off x="16489338" y="9510713"/>
-            <a:ext cx="922362" cy="319088"/>
+            <a:off x="16540535" y="9510713"/>
+            <a:ext cx="871165" cy="319088"/>
           </a:xfrm>
           <a:prstGeom prst="rect">
             <a:avLst/>
@@ -11718,7 +11807,7 @@
                 <a:ea typeface="Arial" pitchFamily="34" charset="-122"/>
                 <a:cs typeface="Arial" pitchFamily="34" charset="-120"/>
               </a:rPr>
-              <a:t>19 · 20</a:t>
+              <a:t>19 · 21</a:t>
             </a:r>
             <a:endParaRPr lang="en-US" sz="1800" dirty="0"/>
           </a:p>
@@ -12198,9 +12287,53 @@
           </a:p>
         </p:txBody>
       </p:sp>
+      <p:sp>
+        <p:nvSpPr>
+          <p:cNvPr id="13" name="Text 11"/>
+          <p:cNvSpPr/>
+          <p:nvPr/>
+        </p:nvSpPr>
+        <p:spPr>
+          <a:xfrm>
+            <a:off x="9937775" y="6821686"/>
+            <a:ext cx="7521549" cy="678061"/>
+          </a:xfrm>
+          <a:prstGeom prst="rect">
+            <a:avLst/>
+          </a:prstGeom>
+          <a:noFill/>
+          <a:ln/>
+        </p:spPr>
+        <p:txBody>
+          <a:bodyPr wrap="square" lIns="25400" tIns="25400" rIns="25400" bIns="25400" rtlCol="0" anchor="t">
+            <a:normAutofit/>
+          </a:bodyPr>
+          <a:lstStyle/>
+          <a:p>
+            <a:pPr algn="l" indent="0" marL="0">
+              <a:lnSpc>
+                <a:spcPct val="140000"/>
+              </a:lnSpc>
+              <a:buNone/>
+            </a:pPr>
+            <a:r>
+              <a:rPr lang="en-US" sz="1800" dirty="0">
+                <a:solidFill>
+                  <a:srgbClr val="B08D74"/>
+                </a:solidFill>
+                <a:latin typeface="Arial" pitchFamily="34" charset="0"/>
+                <a:ea typeface="Arial" pitchFamily="34" charset="-122"/>
+                <a:cs typeface="Arial" pitchFamily="34" charset="-120"/>
+              </a:rPr>
+              <a:t>Sources: Carers UK, State of Caring 2024 · Umbrella review of caregiver mental-health meta-analyses (2025)</a:t>
+            </a:r>
+            <a:endParaRPr lang="en-US" sz="1800" dirty="0"/>
+          </a:p>
+        </p:txBody>
+      </p:sp>
       <p:pic>
         <p:nvPicPr>
-          <p:cNvPr id="13" name="Image 0" descr="preencoded.png">    </p:cNvPr>
+          <p:cNvPr id="14" name="Image 0" descr="preencoded.png">    </p:cNvPr>
           <p:cNvPicPr>
             <a:picLocks noChangeAspect="1"/>
           </p:cNvPicPr>
@@ -12230,7 +12363,7 @@
       </p:pic>
       <p:sp>
         <p:nvSpPr>
-          <p:cNvPr id="14" name="Text 11"/>
+          <p:cNvPr id="15" name="Text 12"/>
           <p:cNvSpPr/>
           <p:nvPr/>
         </p:nvSpPr>
@@ -12271,14 +12404,14 @@
       </p:sp>
       <p:sp>
         <p:nvSpPr>
-          <p:cNvPr id="15" name="Text 12"/>
-          <p:cNvSpPr/>
-          <p:nvPr/>
-        </p:nvSpPr>
-        <p:spPr>
-          <a:xfrm>
-            <a:off x="16440448" y="9510713"/>
-            <a:ext cx="971252" cy="319088"/>
+          <p:cNvPr id="16" name="Text 13"/>
+          <p:cNvSpPr/>
+          <p:nvPr/>
+        </p:nvSpPr>
+        <p:spPr>
+          <a:xfrm>
+            <a:off x="16491645" y="9510713"/>
+            <a:ext cx="920055" cy="319088"/>
           </a:xfrm>
           <a:prstGeom prst="rect">
             <a:avLst/>
@@ -12304,7 +12437,7 @@
                 <a:ea typeface="Arial" pitchFamily="34" charset="-122"/>
                 <a:cs typeface="Arial" pitchFamily="34" charset="-120"/>
               </a:rPr>
-              <a:t>02 · 20</a:t>
+              <a:t>02 · 21</a:t>
             </a:r>
             <a:endParaRPr lang="en-US" sz="1800" dirty="0"/>
           </a:p>
@@ -12928,8 +13061,8 @@
         </p:nvSpPr>
         <p:spPr>
           <a:xfrm>
-            <a:off x="16440448" y="9510713"/>
-            <a:ext cx="971252" cy="319088"/>
+            <a:off x="16491645" y="9510713"/>
+            <a:ext cx="920055" cy="319088"/>
           </a:xfrm>
           <a:prstGeom prst="rect">
             <a:avLst/>
@@ -12955,7 +13088,1171 @@
                 <a:ea typeface="Arial" pitchFamily="34" charset="-122"/>
                 <a:cs typeface="Arial" pitchFamily="34" charset="-120"/>
               </a:rPr>
-              <a:t>20 · 20</a:t>
+              <a:t>20 · 21</a:t>
+            </a:r>
+            <a:endParaRPr lang="en-US" sz="1800" dirty="0"/>
+          </a:p>
+        </p:txBody>
+      </p:sp>
+    </p:spTree>
+  </p:cSld>
+  <p:clrMapOvr>
+    <a:masterClrMapping/>
+  </p:clrMapOvr>
+</p:sld>
+</file>
+
+<file path=ppt/slides/slide21.xml><?xml version="1.0" encoding="utf-8"?>
+<p:sld xmlns:a="http://schemas.openxmlformats.org/drawingml/2006/main" xmlns:r="http://schemas.openxmlformats.org/officeDocument/2006/relationships" xmlns:p="http://schemas.openxmlformats.org/presentationml/2006/main">
+  <p:cSld name="Slide 21">
+    <p:bg>
+      <p:bgPr>
+        <a:solidFill>
+          <a:srgbClr val="FAF2E8"/>
+        </a:solidFill>
+      </p:bgPr>
+    </p:bg>
+    <p:spTree>
+      <p:nvGrpSpPr>
+        <p:cNvPr id="1" name=""/>
+        <p:cNvGrpSpPr/>
+        <p:nvPr/>
+      </p:nvGrpSpPr>
+      <p:grpSpPr>
+        <a:xfrm>
+          <a:off x="0" y="0"/>
+          <a:ext cx="0" cy="0"/>
+          <a:chOff x="0" y="0"/>
+          <a:chExt cx="0" cy="0"/>
+        </a:xfrm>
+      </p:grpSpPr>
+      <p:sp>
+        <p:nvSpPr>
+          <p:cNvPr id="2" name="Text 0"/>
+          <p:cNvSpPr/>
+          <p:nvPr/>
+        </p:nvSpPr>
+        <p:spPr>
+          <a:xfrm>
+            <a:off x="1047750" y="838200"/>
+            <a:ext cx="17811750" cy="300038"/>
+          </a:xfrm>
+          <a:prstGeom prst="rect">
+            <a:avLst/>
+          </a:prstGeom>
+          <a:noFill/>
+          <a:ln/>
+        </p:spPr>
+        <p:txBody>
+          <a:bodyPr wrap="square" lIns="25400" tIns="25400" rIns="25400" bIns="25400" rtlCol="0" anchor="t">
+            <a:normAutofit/>
+          </a:bodyPr>
+          <a:lstStyle/>
+          <a:p>
+            <a:pPr algn="l" indent="0" marL="0">
+              <a:buNone/>
+            </a:pPr>
+            <a:r>
+              <a:rPr lang="en-US" sz="1800" b="1" spc="300" kern="0" dirty="0">
+                <a:solidFill>
+                  <a:srgbClr val="A46349"/>
+                </a:solidFill>
+                <a:latin typeface="Arial" pitchFamily="34" charset="0"/>
+                <a:ea typeface="Arial" pitchFamily="34" charset="-122"/>
+                <a:cs typeface="Arial" pitchFamily="34" charset="-120"/>
+              </a:rPr>
+              <a:t>REFERENCES</a:t>
+            </a:r>
+            <a:endParaRPr lang="en-US" sz="1800" dirty="0"/>
+          </a:p>
+        </p:txBody>
+      </p:sp>
+      <p:sp>
+        <p:nvSpPr>
+          <p:cNvPr id="3" name="Text 1"/>
+          <p:cNvSpPr/>
+          <p:nvPr/>
+        </p:nvSpPr>
+        <p:spPr>
+          <a:xfrm>
+            <a:off x="1047750" y="1252538"/>
+            <a:ext cx="17811750" cy="624780"/>
+          </a:xfrm>
+          <a:prstGeom prst="rect">
+            <a:avLst/>
+          </a:prstGeom>
+          <a:noFill/>
+          <a:ln/>
+        </p:spPr>
+        <p:txBody>
+          <a:bodyPr wrap="square" lIns="25400" tIns="25400" rIns="25400" bIns="25400" rtlCol="0" anchor="t">
+            <a:normAutofit/>
+          </a:bodyPr>
+          <a:lstStyle/>
+          <a:p>
+            <a:pPr algn="l" indent="0" marL="0">
+              <a:lnSpc>
+                <a:spcPct val="110000"/>
+              </a:lnSpc>
+              <a:buNone/>
+            </a:pPr>
+            <a:r>
+              <a:rPr lang="en-US" sz="4200" spc="-37" kern="0" dirty="0">
+                <a:solidFill>
+                  <a:srgbClr val="4A3528"/>
+                </a:solidFill>
+                <a:latin typeface="Georgia" pitchFamily="34" charset="0"/>
+                <a:ea typeface="Georgia" pitchFamily="34" charset="-122"/>
+                <a:cs typeface="Georgia" pitchFamily="34" charset="-120"/>
+              </a:rPr>
+              <a:t>The numbers, sourced.</a:t>
+            </a:r>
+            <a:endParaRPr lang="en-US" sz="4200" dirty="0"/>
+          </a:p>
+        </p:txBody>
+      </p:sp>
+      <p:sp>
+        <p:nvSpPr>
+          <p:cNvPr id="4" name="Shape 2"/>
+          <p:cNvSpPr/>
+          <p:nvPr/>
+        </p:nvSpPr>
+        <p:spPr>
+          <a:xfrm>
+            <a:off x="1047750" y="2258318"/>
+            <a:ext cx="7886700" cy="1539180"/>
+          </a:xfrm>
+          <a:prstGeom prst="roundRect">
+            <a:avLst>
+              <a:gd name="adj" fmla="val 12377"/>
+            </a:avLst>
+          </a:prstGeom>
+          <a:solidFill>
+            <a:srgbClr val="FFFDF8"/>
+          </a:solidFill>
+          <a:ln w="9525">
+            <a:solidFill>
+              <a:srgbClr val="EAD9C8"/>
+            </a:solidFill>
+            <a:prstDash val="solid"/>
+          </a:ln>
+        </p:spPr>
+      </p:sp>
+      <p:sp>
+        <p:nvSpPr>
+          <p:cNvPr id="5" name="Text 3"/>
+          <p:cNvSpPr/>
+          <p:nvPr/>
+        </p:nvSpPr>
+        <p:spPr>
+          <a:xfrm>
+            <a:off x="1362075" y="2515493"/>
+            <a:ext cx="7983855" cy="323850"/>
+          </a:xfrm>
+          <a:prstGeom prst="rect">
+            <a:avLst/>
+          </a:prstGeom>
+          <a:noFill/>
+          <a:ln/>
+        </p:spPr>
+        <p:txBody>
+          <a:bodyPr wrap="square" lIns="25400" tIns="25400" rIns="25400" bIns="25400" rtlCol="0" anchor="t">
+            <a:normAutofit/>
+          </a:bodyPr>
+          <a:lstStyle/>
+          <a:p>
+            <a:pPr algn="l" indent="0" marL="0">
+              <a:buNone/>
+            </a:pPr>
+            <a:r>
+              <a:rPr lang="en-US" sz="1950" b="1" dirty="0">
+                <a:solidFill>
+                  <a:srgbClr val="4A3528"/>
+                </a:solidFill>
+                <a:latin typeface="Arial" pitchFamily="34" charset="0"/>
+                <a:ea typeface="Arial" pitchFamily="34" charset="-122"/>
+                <a:cs typeface="Arial" pitchFamily="34" charset="-120"/>
+              </a:rPr>
+              <a:t>UK: 5.8M unpaid carers · £184bn/yr value of care</a:t>
+            </a:r>
+            <a:endParaRPr lang="en-US" sz="1950" dirty="0"/>
+          </a:p>
+        </p:txBody>
+      </p:sp>
+      <p:sp>
+        <p:nvSpPr>
+          <p:cNvPr id="6" name="Text 4"/>
+          <p:cNvSpPr/>
+          <p:nvPr/>
+        </p:nvSpPr>
+        <p:spPr>
+          <a:xfrm>
+            <a:off x="1362075" y="2877443"/>
+            <a:ext cx="7475792" cy="700980"/>
+          </a:xfrm>
+          <a:prstGeom prst="rect">
+            <a:avLst/>
+          </a:prstGeom>
+          <a:noFill/>
+          <a:ln/>
+        </p:spPr>
+        <p:txBody>
+          <a:bodyPr wrap="square" lIns="25400" tIns="25400" rIns="25400" bIns="25400" rtlCol="0" anchor="t">
+            <a:normAutofit/>
+          </a:bodyPr>
+          <a:lstStyle/>
+          <a:p>
+            <a:pPr algn="l" indent="0" marL="0">
+              <a:lnSpc>
+                <a:spcPct val="145000"/>
+              </a:lnSpc>
+              <a:buNone/>
+            </a:pPr>
+            <a:r>
+              <a:rPr lang="en-US" sz="1800" dirty="0">
+                <a:solidFill>
+                  <a:srgbClr val="7A6152"/>
+                </a:solidFill>
+                <a:latin typeface="Arial" pitchFamily="34" charset="0"/>
+                <a:ea typeface="Arial" pitchFamily="34" charset="-122"/>
+                <a:cs typeface="Arial" pitchFamily="34" charset="-120"/>
+              </a:rPr>
+              <a:t>Carers UK, Key Facts &amp; Figures / Facts About Carers (2025) · </a:t>
+            </a:r>
+            <a:pPr algn="l" indent="0" marL="0">
+              <a:lnSpc>
+                <a:spcPct val="145000"/>
+              </a:lnSpc>
+              <a:buNone/>
+            </a:pPr>
+            <a:r>
+              <a:rPr lang="en-US" sz="1800" dirty="0">
+                <a:solidFill>
+                  <a:srgbClr val="A46349"/>
+                </a:solidFill>
+                <a:latin typeface="Arial" pitchFamily="34" charset="0"/>
+                <a:ea typeface="Arial" pitchFamily="34" charset="-122"/>
+                <a:cs typeface="Arial" pitchFamily="34" charset="-120"/>
+              </a:rPr>
+              <a:t>carersuk.org</a:t>
+            </a:r>
+            <a:endParaRPr lang="en-US" sz="1800" dirty="0"/>
+          </a:p>
+        </p:txBody>
+      </p:sp>
+      <p:sp>
+        <p:nvSpPr>
+          <p:cNvPr id="7" name="Shape 5"/>
+          <p:cNvSpPr/>
+          <p:nvPr/>
+        </p:nvSpPr>
+        <p:spPr>
+          <a:xfrm>
+            <a:off x="9353550" y="2258318"/>
+            <a:ext cx="7886700" cy="1539180"/>
+          </a:xfrm>
+          <a:prstGeom prst="roundRect">
+            <a:avLst>
+              <a:gd name="adj" fmla="val 12377"/>
+            </a:avLst>
+          </a:prstGeom>
+          <a:solidFill>
+            <a:srgbClr val="FFFDF8"/>
+          </a:solidFill>
+          <a:ln w="9525">
+            <a:solidFill>
+              <a:srgbClr val="EAD9C8"/>
+            </a:solidFill>
+            <a:prstDash val="solid"/>
+          </a:ln>
+        </p:spPr>
+      </p:sp>
+      <p:sp>
+        <p:nvSpPr>
+          <p:cNvPr id="8" name="Text 6"/>
+          <p:cNvSpPr/>
+          <p:nvPr/>
+        </p:nvSpPr>
+        <p:spPr>
+          <a:xfrm>
+            <a:off x="9667875" y="2515493"/>
+            <a:ext cx="7983855" cy="323850"/>
+          </a:xfrm>
+          <a:prstGeom prst="rect">
+            <a:avLst/>
+          </a:prstGeom>
+          <a:noFill/>
+          <a:ln/>
+        </p:spPr>
+        <p:txBody>
+          <a:bodyPr wrap="square" lIns="25400" tIns="25400" rIns="25400" bIns="25400" rtlCol="0" anchor="t">
+            <a:normAutofit/>
+          </a:bodyPr>
+          <a:lstStyle/>
+          <a:p>
+            <a:pPr algn="l" indent="0" marL="0">
+              <a:buNone/>
+            </a:pPr>
+            <a:r>
+              <a:rPr lang="en-US" sz="1950" b="1" dirty="0">
+                <a:solidFill>
+                  <a:srgbClr val="4A3528"/>
+                </a:solidFill>
+                <a:latin typeface="Arial" pitchFamily="34" charset="0"/>
+                <a:ea typeface="Arial" pitchFamily="34" charset="-122"/>
+                <a:cs typeface="Arial" pitchFamily="34" charset="-120"/>
+              </a:rPr>
+              <a:t>UK: 63% say caring harms their mental health</a:t>
+            </a:r>
+            <a:endParaRPr lang="en-US" sz="1950" dirty="0"/>
+          </a:p>
+        </p:txBody>
+      </p:sp>
+      <p:sp>
+        <p:nvSpPr>
+          <p:cNvPr id="9" name="Text 7"/>
+          <p:cNvSpPr/>
+          <p:nvPr/>
+        </p:nvSpPr>
+        <p:spPr>
+          <a:xfrm>
+            <a:off x="9667875" y="2877443"/>
+            <a:ext cx="7983855" cy="369540"/>
+          </a:xfrm>
+          <a:prstGeom prst="rect">
+            <a:avLst/>
+          </a:prstGeom>
+          <a:noFill/>
+          <a:ln/>
+        </p:spPr>
+        <p:txBody>
+          <a:bodyPr wrap="square" lIns="25400" tIns="25400" rIns="25400" bIns="25400" rtlCol="0" anchor="t">
+            <a:normAutofit/>
+          </a:bodyPr>
+          <a:lstStyle/>
+          <a:p>
+            <a:pPr algn="l" indent="0" marL="0">
+              <a:lnSpc>
+                <a:spcPct val="145000"/>
+              </a:lnSpc>
+              <a:buNone/>
+            </a:pPr>
+            <a:r>
+              <a:rPr lang="en-US" sz="1800" dirty="0">
+                <a:solidFill>
+                  <a:srgbClr val="7A6152"/>
+                </a:solidFill>
+                <a:latin typeface="Arial" pitchFamily="34" charset="0"/>
+                <a:ea typeface="Arial" pitchFamily="34" charset="-122"/>
+                <a:cs typeface="Arial" pitchFamily="34" charset="-120"/>
+              </a:rPr>
+              <a:t>Carers UK, State of Caring 2024</a:t>
+            </a:r>
+            <a:endParaRPr lang="en-US" sz="1800" dirty="0"/>
+          </a:p>
+        </p:txBody>
+      </p:sp>
+      <p:sp>
+        <p:nvSpPr>
+          <p:cNvPr id="10" name="Shape 8"/>
+          <p:cNvSpPr/>
+          <p:nvPr/>
+        </p:nvSpPr>
+        <p:spPr>
+          <a:xfrm>
+            <a:off x="1047750" y="4007048"/>
+            <a:ext cx="7886700" cy="1207740"/>
+          </a:xfrm>
+          <a:prstGeom prst="roundRect">
+            <a:avLst>
+              <a:gd name="adj" fmla="val 15773"/>
+            </a:avLst>
+          </a:prstGeom>
+          <a:solidFill>
+            <a:srgbClr val="FFFDF8"/>
+          </a:solidFill>
+          <a:ln w="9525">
+            <a:solidFill>
+              <a:srgbClr val="EAD9C8"/>
+            </a:solidFill>
+            <a:prstDash val="solid"/>
+          </a:ln>
+        </p:spPr>
+      </p:sp>
+      <p:sp>
+        <p:nvSpPr>
+          <p:cNvPr id="11" name="Text 9"/>
+          <p:cNvSpPr/>
+          <p:nvPr/>
+        </p:nvSpPr>
+        <p:spPr>
+          <a:xfrm>
+            <a:off x="1362075" y="4264223"/>
+            <a:ext cx="7983855" cy="323850"/>
+          </a:xfrm>
+          <a:prstGeom prst="rect">
+            <a:avLst/>
+          </a:prstGeom>
+          <a:noFill/>
+          <a:ln/>
+        </p:spPr>
+        <p:txBody>
+          <a:bodyPr wrap="square" lIns="25400" tIns="25400" rIns="25400" bIns="25400" rtlCol="0" anchor="t">
+            <a:normAutofit/>
+          </a:bodyPr>
+          <a:lstStyle/>
+          <a:p>
+            <a:pPr algn="l" indent="0" marL="0">
+              <a:buNone/>
+            </a:pPr>
+            <a:r>
+              <a:rPr lang="en-US" sz="1950" b="1" dirty="0">
+                <a:solidFill>
+                  <a:srgbClr val="4A3528"/>
+                </a:solidFill>
+                <a:latin typeface="Arial" pitchFamily="34" charset="0"/>
+                <a:ea typeface="Arial" pitchFamily="34" charset="-122"/>
+                <a:cs typeface="Arial" pitchFamily="34" charset="-120"/>
+              </a:rPr>
+              <a:t>US: 63M family caregivers, +45% since 2015</a:t>
+            </a:r>
+            <a:endParaRPr lang="en-US" sz="1950" dirty="0"/>
+          </a:p>
+        </p:txBody>
+      </p:sp>
+      <p:sp>
+        <p:nvSpPr>
+          <p:cNvPr id="12" name="Text 10"/>
+          <p:cNvSpPr/>
+          <p:nvPr/>
+        </p:nvSpPr>
+        <p:spPr>
+          <a:xfrm>
+            <a:off x="1362075" y="4626173"/>
+            <a:ext cx="7983855" cy="369540"/>
+          </a:xfrm>
+          <a:prstGeom prst="rect">
+            <a:avLst/>
+          </a:prstGeom>
+          <a:noFill/>
+          <a:ln/>
+        </p:spPr>
+        <p:txBody>
+          <a:bodyPr wrap="square" lIns="25400" tIns="25400" rIns="25400" bIns="25400" rtlCol="0" anchor="t">
+            <a:normAutofit/>
+          </a:bodyPr>
+          <a:lstStyle/>
+          <a:p>
+            <a:pPr algn="l" indent="0" marL="0">
+              <a:lnSpc>
+                <a:spcPct val="145000"/>
+              </a:lnSpc>
+              <a:buNone/>
+            </a:pPr>
+            <a:r>
+              <a:rPr lang="en-US" sz="1800" dirty="0">
+                <a:solidFill>
+                  <a:srgbClr val="7A6152"/>
+                </a:solidFill>
+                <a:latin typeface="Arial" pitchFamily="34" charset="0"/>
+                <a:ea typeface="Arial" pitchFamily="34" charset="-122"/>
+                <a:cs typeface="Arial" pitchFamily="34" charset="-120"/>
+              </a:rPr>
+              <a:t>AARP &amp; National Alliance for Caregiving, Caregiving in the US 2025</a:t>
+            </a:r>
+            <a:endParaRPr lang="en-US" sz="1800" dirty="0"/>
+          </a:p>
+        </p:txBody>
+      </p:sp>
+      <p:sp>
+        <p:nvSpPr>
+          <p:cNvPr id="13" name="Shape 11"/>
+          <p:cNvSpPr/>
+          <p:nvPr/>
+        </p:nvSpPr>
+        <p:spPr>
+          <a:xfrm>
+            <a:off x="9353550" y="4007048"/>
+            <a:ext cx="7886700" cy="1207740"/>
+          </a:xfrm>
+          <a:prstGeom prst="roundRect">
+            <a:avLst>
+              <a:gd name="adj" fmla="val 15773"/>
+            </a:avLst>
+          </a:prstGeom>
+          <a:solidFill>
+            <a:srgbClr val="FFFDF8"/>
+          </a:solidFill>
+          <a:ln w="9525">
+            <a:solidFill>
+              <a:srgbClr val="EAD9C8"/>
+            </a:solidFill>
+            <a:prstDash val="solid"/>
+          </a:ln>
+        </p:spPr>
+      </p:sp>
+      <p:sp>
+        <p:nvSpPr>
+          <p:cNvPr id="14" name="Text 12"/>
+          <p:cNvSpPr/>
+          <p:nvPr/>
+        </p:nvSpPr>
+        <p:spPr>
+          <a:xfrm>
+            <a:off x="9667875" y="4264223"/>
+            <a:ext cx="7983855" cy="323850"/>
+          </a:xfrm>
+          <a:prstGeom prst="rect">
+            <a:avLst/>
+          </a:prstGeom>
+          <a:noFill/>
+          <a:ln/>
+        </p:spPr>
+        <p:txBody>
+          <a:bodyPr wrap="square" lIns="25400" tIns="25400" rIns="25400" bIns="25400" rtlCol="0" anchor="t">
+            <a:normAutofit/>
+          </a:bodyPr>
+          <a:lstStyle/>
+          <a:p>
+            <a:pPr algn="l" indent="0" marL="0">
+              <a:buNone/>
+            </a:pPr>
+            <a:r>
+              <a:rPr lang="en-US" sz="1950" b="1" dirty="0">
+                <a:solidFill>
+                  <a:srgbClr val="4A3528"/>
+                </a:solidFill>
+                <a:latin typeface="Arial" pitchFamily="34" charset="0"/>
+                <a:ea typeface="Arial" pitchFamily="34" charset="-122"/>
+                <a:cs typeface="Arial" pitchFamily="34" charset="-120"/>
+              </a:rPr>
+              <a:t>US: $1.01 trillion/yr value of unpaid care</a:t>
+            </a:r>
+            <a:endParaRPr lang="en-US" sz="1950" dirty="0"/>
+          </a:p>
+        </p:txBody>
+      </p:sp>
+      <p:sp>
+        <p:nvSpPr>
+          <p:cNvPr id="15" name="Text 13"/>
+          <p:cNvSpPr/>
+          <p:nvPr/>
+        </p:nvSpPr>
+        <p:spPr>
+          <a:xfrm>
+            <a:off x="9667875" y="4626173"/>
+            <a:ext cx="7983855" cy="369540"/>
+          </a:xfrm>
+          <a:prstGeom prst="rect">
+            <a:avLst/>
+          </a:prstGeom>
+          <a:noFill/>
+          <a:ln/>
+        </p:spPr>
+        <p:txBody>
+          <a:bodyPr wrap="square" lIns="25400" tIns="25400" rIns="25400" bIns="25400" rtlCol="0" anchor="t">
+            <a:normAutofit/>
+          </a:bodyPr>
+          <a:lstStyle/>
+          <a:p>
+            <a:pPr algn="l" indent="0" marL="0">
+              <a:lnSpc>
+                <a:spcPct val="145000"/>
+              </a:lnSpc>
+              <a:buNone/>
+            </a:pPr>
+            <a:r>
+              <a:rPr lang="en-US" sz="1800" dirty="0">
+                <a:solidFill>
+                  <a:srgbClr val="7A6152"/>
+                </a:solidFill>
+                <a:latin typeface="Arial" pitchFamily="34" charset="0"/>
+                <a:ea typeface="Arial" pitchFamily="34" charset="-122"/>
+                <a:cs typeface="Arial" pitchFamily="34" charset="-120"/>
+              </a:rPr>
+              <a:t>AARP, Valuing the Invaluable (2026 update) · </a:t>
+            </a:r>
+            <a:pPr algn="l" indent="0" marL="0">
+              <a:lnSpc>
+                <a:spcPct val="145000"/>
+              </a:lnSpc>
+              <a:buNone/>
+            </a:pPr>
+            <a:r>
+              <a:rPr lang="en-US" sz="1800" dirty="0">
+                <a:solidFill>
+                  <a:srgbClr val="A46349"/>
+                </a:solidFill>
+                <a:latin typeface="Arial" pitchFamily="34" charset="0"/>
+                <a:ea typeface="Arial" pitchFamily="34" charset="-122"/>
+                <a:cs typeface="Arial" pitchFamily="34" charset="-120"/>
+              </a:rPr>
+              <a:t>aarp.org</a:t>
+            </a:r>
+            <a:endParaRPr lang="en-US" sz="1800" dirty="0"/>
+          </a:p>
+        </p:txBody>
+      </p:sp>
+      <p:sp>
+        <p:nvSpPr>
+          <p:cNvPr id="16" name="Shape 14"/>
+          <p:cNvSpPr/>
+          <p:nvPr/>
+        </p:nvSpPr>
+        <p:spPr>
+          <a:xfrm>
+            <a:off x="1047750" y="5424339"/>
+            <a:ext cx="7886700" cy="1824930"/>
+          </a:xfrm>
+          <a:prstGeom prst="roundRect">
+            <a:avLst>
+              <a:gd name="adj" fmla="val 10439"/>
+            </a:avLst>
+          </a:prstGeom>
+          <a:solidFill>
+            <a:srgbClr val="FFFDF8"/>
+          </a:solidFill>
+          <a:ln w="9525">
+            <a:solidFill>
+              <a:srgbClr val="EAD9C8"/>
+            </a:solidFill>
+            <a:prstDash val="solid"/>
+          </a:ln>
+        </p:spPr>
+      </p:sp>
+      <p:sp>
+        <p:nvSpPr>
+          <p:cNvPr id="17" name="Text 15"/>
+          <p:cNvSpPr/>
+          <p:nvPr/>
+        </p:nvSpPr>
+        <p:spPr>
+          <a:xfrm>
+            <a:off x="1362075" y="5681514"/>
+            <a:ext cx="7983855" cy="323850"/>
+          </a:xfrm>
+          <a:prstGeom prst="rect">
+            <a:avLst/>
+          </a:prstGeom>
+          <a:noFill/>
+          <a:ln/>
+        </p:spPr>
+        <p:txBody>
+          <a:bodyPr wrap="square" lIns="25400" tIns="25400" rIns="25400" bIns="25400" rtlCol="0" anchor="t">
+            <a:normAutofit/>
+          </a:bodyPr>
+          <a:lstStyle/>
+          <a:p>
+            <a:pPr algn="l" indent="0" marL="0">
+              <a:buNone/>
+            </a:pPr>
+            <a:r>
+              <a:rPr lang="en-US" sz="1950" b="1" dirty="0">
+                <a:solidFill>
+                  <a:srgbClr val="4A3528"/>
+                </a:solidFill>
+                <a:latin typeface="Arial" pitchFamily="34" charset="0"/>
+                <a:ea typeface="Arial" pitchFamily="34" charset="-122"/>
+                <a:cs typeface="Arial" pitchFamily="34" charset="-120"/>
+              </a:rPr>
+              <a:t>~1 in 5 carers at risk of burnout</a:t>
+            </a:r>
+            <a:endParaRPr lang="en-US" sz="1950" dirty="0"/>
+          </a:p>
+        </p:txBody>
+      </p:sp>
+      <p:sp>
+        <p:nvSpPr>
+          <p:cNvPr id="18" name="Text 16"/>
+          <p:cNvSpPr/>
+          <p:nvPr/>
+        </p:nvSpPr>
+        <p:spPr>
+          <a:xfrm>
+            <a:off x="1362075" y="6043464"/>
+            <a:ext cx="7475792" cy="700980"/>
+          </a:xfrm>
+          <a:prstGeom prst="rect">
+            <a:avLst/>
+          </a:prstGeom>
+          <a:noFill/>
+          <a:ln/>
+        </p:spPr>
+        <p:txBody>
+          <a:bodyPr wrap="square" lIns="25400" tIns="25400" rIns="25400" bIns="25400" rtlCol="0" anchor="t">
+            <a:normAutofit/>
+          </a:bodyPr>
+          <a:lstStyle/>
+          <a:p>
+            <a:pPr algn="l" indent="0" marL="0">
+              <a:lnSpc>
+                <a:spcPct val="145000"/>
+              </a:lnSpc>
+              <a:buNone/>
+            </a:pPr>
+            <a:r>
+              <a:rPr lang="en-US" sz="1800" dirty="0">
+                <a:solidFill>
+                  <a:srgbClr val="7A6152"/>
+                </a:solidFill>
+                <a:latin typeface="Arial" pitchFamily="34" charset="0"/>
+                <a:ea typeface="Arial" pitchFamily="34" charset="-122"/>
+                <a:cs typeface="Arial" pitchFamily="34" charset="-120"/>
+              </a:rPr>
+              <a:t>Umbrella review of informal-caregiver mental-health meta-analyses (2025) · </a:t>
+            </a:r>
+            <a:pPr algn="l" indent="0" marL="0">
+              <a:lnSpc>
+                <a:spcPct val="145000"/>
+              </a:lnSpc>
+              <a:buNone/>
+            </a:pPr>
+            <a:r>
+              <a:rPr lang="en-US" sz="1800" dirty="0">
+                <a:solidFill>
+                  <a:srgbClr val="A46349"/>
+                </a:solidFill>
+                <a:latin typeface="Arial" pitchFamily="34" charset="0"/>
+                <a:ea typeface="Arial" pitchFamily="34" charset="-122"/>
+                <a:cs typeface="Arial" pitchFamily="34" charset="-120"/>
+              </a:rPr>
+              <a:t>sciencedirect.com</a:t>
+            </a:r>
+            <a:endParaRPr lang="en-US" sz="1800" dirty="0"/>
+          </a:p>
+        </p:txBody>
+      </p:sp>
+      <p:sp>
+        <p:nvSpPr>
+          <p:cNvPr id="19" name="Shape 17"/>
+          <p:cNvSpPr/>
+          <p:nvPr/>
+        </p:nvSpPr>
+        <p:spPr>
+          <a:xfrm>
+            <a:off x="9353550" y="5424339"/>
+            <a:ext cx="7886700" cy="1824930"/>
+          </a:xfrm>
+          <a:prstGeom prst="roundRect">
+            <a:avLst>
+              <a:gd name="adj" fmla="val 10439"/>
+            </a:avLst>
+          </a:prstGeom>
+          <a:solidFill>
+            <a:srgbClr val="FFFDF8"/>
+          </a:solidFill>
+          <a:ln w="9525">
+            <a:solidFill>
+              <a:srgbClr val="EAD9C8"/>
+            </a:solidFill>
+            <a:prstDash val="solid"/>
+          </a:ln>
+        </p:spPr>
+      </p:sp>
+      <p:sp>
+        <p:nvSpPr>
+          <p:cNvPr id="20" name="Text 18"/>
+          <p:cNvSpPr/>
+          <p:nvPr/>
+        </p:nvSpPr>
+        <p:spPr>
+          <a:xfrm>
+            <a:off x="9667875" y="5681514"/>
+            <a:ext cx="7475792" cy="609600"/>
+          </a:xfrm>
+          <a:prstGeom prst="rect">
+            <a:avLst/>
+          </a:prstGeom>
+          <a:noFill/>
+          <a:ln/>
+        </p:spPr>
+        <p:txBody>
+          <a:bodyPr wrap="square" lIns="25400" tIns="25400" rIns="25400" bIns="25400" rtlCol="0" anchor="t">
+            <a:normAutofit/>
+          </a:bodyPr>
+          <a:lstStyle/>
+          <a:p>
+            <a:pPr algn="l" indent="0" marL="0">
+              <a:buNone/>
+            </a:pPr>
+            <a:r>
+              <a:rPr lang="en-US" sz="1950" b="1" dirty="0">
+                <a:solidFill>
+                  <a:srgbClr val="4A3528"/>
+                </a:solidFill>
+                <a:latin typeface="Arial" pitchFamily="34" charset="0"/>
+                <a:ea typeface="Arial" pitchFamily="34" charset="-122"/>
+                <a:cs typeface="Arial" pitchFamily="34" charset="-120"/>
+              </a:rPr>
+              <a:t>Digital mental health: ~$33bn (2025) → ~$180bn (2035), ~18.5% CAGR</a:t>
+            </a:r>
+            <a:endParaRPr lang="en-US" sz="1950" dirty="0"/>
+          </a:p>
+        </p:txBody>
+      </p:sp>
+      <p:sp>
+        <p:nvSpPr>
+          <p:cNvPr id="21" name="Text 19"/>
+          <p:cNvSpPr/>
+          <p:nvPr/>
+        </p:nvSpPr>
+        <p:spPr>
+          <a:xfrm>
+            <a:off x="9667875" y="6329214"/>
+            <a:ext cx="7475792" cy="700980"/>
+          </a:xfrm>
+          <a:prstGeom prst="rect">
+            <a:avLst/>
+          </a:prstGeom>
+          <a:noFill/>
+          <a:ln/>
+        </p:spPr>
+        <p:txBody>
+          <a:bodyPr wrap="square" lIns="25400" tIns="25400" rIns="25400" bIns="25400" rtlCol="0" anchor="t">
+            <a:normAutofit/>
+          </a:bodyPr>
+          <a:lstStyle/>
+          <a:p>
+            <a:pPr algn="l" indent="0" marL="0">
+              <a:lnSpc>
+                <a:spcPct val="145000"/>
+              </a:lnSpc>
+              <a:buNone/>
+            </a:pPr>
+            <a:r>
+              <a:rPr lang="en-US" sz="1800" dirty="0">
+                <a:solidFill>
+                  <a:srgbClr val="7A6152"/>
+                </a:solidFill>
+                <a:latin typeface="Arial" pitchFamily="34" charset="0"/>
+                <a:ea typeface="Arial" pitchFamily="34" charset="-122"/>
+                <a:cs typeface="Arial" pitchFamily="34" charset="-120"/>
+              </a:rPr>
+              <a:t>Market Research Future, Digital Mental Health Market (2025) · </a:t>
+            </a:r>
+            <a:pPr algn="l" indent="0" marL="0">
+              <a:lnSpc>
+                <a:spcPct val="145000"/>
+              </a:lnSpc>
+              <a:buNone/>
+            </a:pPr>
+            <a:r>
+              <a:rPr lang="en-US" sz="1800" dirty="0">
+                <a:solidFill>
+                  <a:srgbClr val="A46349"/>
+                </a:solidFill>
+                <a:latin typeface="Arial" pitchFamily="34" charset="0"/>
+                <a:ea typeface="Arial" pitchFamily="34" charset="-122"/>
+                <a:cs typeface="Arial" pitchFamily="34" charset="-120"/>
+              </a:rPr>
+              <a:t>marketresearchfuture.com</a:t>
+            </a:r>
+            <a:endParaRPr lang="en-US" sz="1800" dirty="0"/>
+          </a:p>
+        </p:txBody>
+      </p:sp>
+      <p:sp>
+        <p:nvSpPr>
+          <p:cNvPr id="22" name="Shape 20"/>
+          <p:cNvSpPr/>
+          <p:nvPr/>
+        </p:nvSpPr>
+        <p:spPr>
+          <a:xfrm>
+            <a:off x="1047750" y="7458819"/>
+            <a:ext cx="7886700" cy="1207740"/>
+          </a:xfrm>
+          <a:prstGeom prst="roundRect">
+            <a:avLst>
+              <a:gd name="adj" fmla="val 15773"/>
+            </a:avLst>
+          </a:prstGeom>
+          <a:solidFill>
+            <a:srgbClr val="FFFDF8"/>
+          </a:solidFill>
+          <a:ln w="9525">
+            <a:solidFill>
+              <a:srgbClr val="EAD9C8"/>
+            </a:solidFill>
+            <a:prstDash val="solid"/>
+          </a:ln>
+        </p:spPr>
+      </p:sp>
+      <p:sp>
+        <p:nvSpPr>
+          <p:cNvPr id="23" name="Text 21"/>
+          <p:cNvSpPr/>
+          <p:nvPr/>
+        </p:nvSpPr>
+        <p:spPr>
+          <a:xfrm>
+            <a:off x="1362075" y="7715994"/>
+            <a:ext cx="7983855" cy="323850"/>
+          </a:xfrm>
+          <a:prstGeom prst="rect">
+            <a:avLst/>
+          </a:prstGeom>
+          <a:noFill/>
+          <a:ln/>
+        </p:spPr>
+        <p:txBody>
+          <a:bodyPr wrap="square" lIns="25400" tIns="25400" rIns="25400" bIns="25400" rtlCol="0" anchor="t">
+            <a:normAutofit/>
+          </a:bodyPr>
+          <a:lstStyle/>
+          <a:p>
+            <a:pPr algn="l" indent="0" marL="0">
+              <a:buNone/>
+            </a:pPr>
+            <a:r>
+              <a:rPr lang="en-US" sz="1950" b="1" dirty="0">
+                <a:solidFill>
+                  <a:srgbClr val="4A3528"/>
+                </a:solidFill>
+                <a:latin typeface="Arial" pitchFamily="34" charset="0"/>
+                <a:ea typeface="Arial" pitchFamily="34" charset="-122"/>
+                <a:cs typeface="Arial" pitchFamily="34" charset="-120"/>
+              </a:rPr>
+              <a:t>Mental-health apps: ~$9bn (2025) → ~$23bn (2030)</a:t>
+            </a:r>
+            <a:endParaRPr lang="en-US" sz="1950" dirty="0"/>
+          </a:p>
+        </p:txBody>
+      </p:sp>
+      <p:sp>
+        <p:nvSpPr>
+          <p:cNvPr id="24" name="Text 22"/>
+          <p:cNvSpPr/>
+          <p:nvPr/>
+        </p:nvSpPr>
+        <p:spPr>
+          <a:xfrm>
+            <a:off x="1362075" y="8077944"/>
+            <a:ext cx="7983855" cy="369540"/>
+          </a:xfrm>
+          <a:prstGeom prst="rect">
+            <a:avLst/>
+          </a:prstGeom>
+          <a:noFill/>
+          <a:ln/>
+        </p:spPr>
+        <p:txBody>
+          <a:bodyPr wrap="square" lIns="25400" tIns="25400" rIns="25400" bIns="25400" rtlCol="0" anchor="t">
+            <a:normAutofit/>
+          </a:bodyPr>
+          <a:lstStyle/>
+          <a:p>
+            <a:pPr algn="l" indent="0" marL="0">
+              <a:lnSpc>
+                <a:spcPct val="145000"/>
+              </a:lnSpc>
+              <a:buNone/>
+            </a:pPr>
+            <a:r>
+              <a:rPr lang="en-US" sz="1800" dirty="0">
+                <a:solidFill>
+                  <a:srgbClr val="7A6152"/>
+                </a:solidFill>
+                <a:latin typeface="Arial" pitchFamily="34" charset="0"/>
+                <a:ea typeface="Arial" pitchFamily="34" charset="-122"/>
+                <a:cs typeface="Arial" pitchFamily="34" charset="-120"/>
+              </a:rPr>
+              <a:t>MarketsandMarkets, Mental Health Apps Market (2025)</a:t>
+            </a:r>
+            <a:endParaRPr lang="en-US" sz="1800" dirty="0"/>
+          </a:p>
+        </p:txBody>
+      </p:sp>
+      <p:sp>
+        <p:nvSpPr>
+          <p:cNvPr id="25" name="Shape 23"/>
+          <p:cNvSpPr/>
+          <p:nvPr/>
+        </p:nvSpPr>
+        <p:spPr>
+          <a:xfrm>
+            <a:off x="9353550" y="7458819"/>
+            <a:ext cx="7886700" cy="1207740"/>
+          </a:xfrm>
+          <a:prstGeom prst="roundRect">
+            <a:avLst>
+              <a:gd name="adj" fmla="val 15773"/>
+            </a:avLst>
+          </a:prstGeom>
+          <a:gradFill rotWithShape="1">
+            <a:gsLst>
+              <a:gs pos="0">
+                <a:srgbClr val="F4CDA6">
+                  <a:alpha val="40000"/>
+                </a:srgbClr>
+              </a:gs>
+              <a:gs pos="100000">
+                <a:srgbClr val="D5A3B2">
+                  <a:alpha val="35000"/>
+                </a:srgbClr>
+              </a:gs>
+            </a:gsLst>
+            <a:lin ang="3600000" scaled="0"/>
+          </a:gradFill>
+          <a:ln w="9525">
+            <a:solidFill>
+              <a:srgbClr val="EAD9C8"/>
+            </a:solidFill>
+            <a:prstDash val="solid"/>
+          </a:ln>
+        </p:spPr>
+      </p:sp>
+      <p:sp>
+        <p:nvSpPr>
+          <p:cNvPr id="26" name="Text 24"/>
+          <p:cNvSpPr/>
+          <p:nvPr/>
+        </p:nvSpPr>
+        <p:spPr>
+          <a:xfrm>
+            <a:off x="9667875" y="7717408"/>
+            <a:ext cx="7475792" cy="728663"/>
+          </a:xfrm>
+          <a:prstGeom prst="rect">
+            <a:avLst/>
+          </a:prstGeom>
+          <a:noFill/>
+          <a:ln/>
+        </p:spPr>
+        <p:txBody>
+          <a:bodyPr wrap="square" lIns="25400" tIns="25400" rIns="25400" bIns="25400" rtlCol="0" anchor="t">
+            <a:normAutofit/>
+          </a:bodyPr>
+          <a:lstStyle/>
+          <a:p>
+            <a:pPr algn="l" indent="0" marL="0">
+              <a:lnSpc>
+                <a:spcPct val="145000"/>
+              </a:lnSpc>
+              <a:buNone/>
+            </a:pPr>
+            <a:r>
+              <a:rPr lang="en-US" sz="1875" i="1" dirty="0">
+                <a:solidFill>
+                  <a:srgbClr val="5F4130"/>
+                </a:solidFill>
+                <a:latin typeface="Georgia" pitchFamily="34" charset="0"/>
+                <a:ea typeface="Georgia" pitchFamily="34" charset="-122"/>
+                <a:cs typeface="Georgia" pitchFamily="34" charset="-120"/>
+              </a:rPr>
+              <a:t>Market figures are third-party estimates; ranges reflect differing methodologies.</a:t>
+            </a:r>
+            <a:endParaRPr lang="en-US" sz="1875" dirty="0"/>
+          </a:p>
+        </p:txBody>
+      </p:sp>
+      <p:pic>
+        <p:nvPicPr>
+          <p:cNvPr id="27" name="Image 0" descr="preencoded.png">    </p:cNvPr>
+          <p:cNvPicPr>
+            <a:picLocks noChangeAspect="1"/>
+          </p:cNvPicPr>
+          <p:nvPr/>
+        </p:nvPicPr>
+        <p:blipFill>
+          <a:blip r:embed="rId1">
+            <a:extLst>
+              <a:ext uri="{96DAC541-7B7A-43D3-8B79-37D633B846F1}">
+                <asvg:svgBlip xmlns:asvg="http://schemas.microsoft.com/office/drawing/2016/SVG/main" r:embed="rId2"/>
+              </a:ext>
+            </a:extLst>
+          </a:blip>
+          <a:stretch>
+            <a:fillRect/>
+          </a:stretch>
+        </p:blipFill>
+        <p:spPr>
+          <a:xfrm>
+            <a:off x="952500" y="9541669"/>
+            <a:ext cx="247650" cy="247650"/>
+          </a:xfrm>
+          <a:prstGeom prst="rect">
+            <a:avLst/>
+          </a:prstGeom>
+        </p:spPr>
+      </p:pic>
+      <p:sp>
+        <p:nvSpPr>
+          <p:cNvPr id="28" name="Text 25"/>
+          <p:cNvSpPr/>
+          <p:nvPr/>
+        </p:nvSpPr>
+        <p:spPr>
+          <a:xfrm>
+            <a:off x="1304925" y="9520238"/>
+            <a:ext cx="635645" cy="328613"/>
+          </a:xfrm>
+          <a:prstGeom prst="rect">
+            <a:avLst/>
+          </a:prstGeom>
+          <a:noFill/>
+          <a:ln/>
+        </p:spPr>
+        <p:txBody>
+          <a:bodyPr wrap="square" lIns="25400" tIns="25400" rIns="25400" bIns="25400" rtlCol="0" anchor="t">
+            <a:normAutofit/>
+          </a:bodyPr>
+          <a:lstStyle/>
+          <a:p>
+            <a:pPr algn="l" indent="0" marL="0">
+              <a:buNone/>
+            </a:pPr>
+            <a:r>
+              <a:rPr lang="en-US" sz="1800" dirty="0">
+                <a:solidFill>
+                  <a:srgbClr val="A46349"/>
+                </a:solidFill>
+                <a:latin typeface="Georgia" pitchFamily="34" charset="0"/>
+                <a:ea typeface="Georgia" pitchFamily="34" charset="-122"/>
+                <a:cs typeface="Georgia" pitchFamily="34" charset="-120"/>
+              </a:rPr>
+              <a:t>carer</a:t>
+            </a:r>
+            <a:endParaRPr lang="en-US" sz="1800" dirty="0"/>
+          </a:p>
+        </p:txBody>
+      </p:sp>
+      <p:sp>
+        <p:nvSpPr>
+          <p:cNvPr id="29" name="Text 26"/>
+          <p:cNvSpPr/>
+          <p:nvPr/>
+        </p:nvSpPr>
+        <p:spPr>
+          <a:xfrm>
+            <a:off x="16542916" y="9510713"/>
+            <a:ext cx="868784" cy="319088"/>
+          </a:xfrm>
+          <a:prstGeom prst="rect">
+            <a:avLst/>
+          </a:prstGeom>
+          <a:noFill/>
+          <a:ln/>
+        </p:spPr>
+        <p:txBody>
+          <a:bodyPr wrap="square" lIns="25400" tIns="25400" rIns="25400" bIns="25400" rtlCol="0" anchor="t">
+            <a:normAutofit/>
+          </a:bodyPr>
+          <a:lstStyle/>
+          <a:p>
+            <a:pPr algn="l" indent="0" marL="0">
+              <a:buNone/>
+            </a:pPr>
+            <a:r>
+              <a:rPr lang="en-US" sz="1800" spc="150" kern="0" dirty="0">
+                <a:solidFill>
+                  <a:srgbClr val="B08D74"/>
+                </a:solidFill>
+                <a:latin typeface="Arial" pitchFamily="34" charset="0"/>
+                <a:ea typeface="Arial" pitchFamily="34" charset="-122"/>
+                <a:cs typeface="Arial" pitchFamily="34" charset="-120"/>
+              </a:rPr>
+              <a:t>21 · 21</a:t>
             </a:r>
             <a:endParaRPr lang="en-US" sz="1800" dirty="0"/>
           </a:p>
@@ -13711,7 +15008,7 @@
                 <a:ea typeface="Arial" pitchFamily="34" charset="-122"/>
                 <a:cs typeface="Arial" pitchFamily="34" charset="-120"/>
               </a:rPr>
-              <a:t>Sources: Carers UK 2025 · AARP 2026</a:t>
+              <a:t>Sources: Carers UK, Key Facts &amp; Figures (2025) · AARP &amp; NAC, Caregiving in the US 2025 · AARP, Valuing the Invaluable (2026 update)</a:t>
             </a:r>
             <a:endParaRPr lang="en-US" sz="1800" dirty="0"/>
           </a:p>
@@ -13796,8 +15093,8 @@
         </p:nvSpPr>
         <p:spPr>
           <a:xfrm>
-            <a:off x="16438662" y="9510713"/>
-            <a:ext cx="973038" cy="319088"/>
+            <a:off x="16489859" y="9510713"/>
+            <a:ext cx="921841" cy="319088"/>
           </a:xfrm>
           <a:prstGeom prst="rect">
             <a:avLst/>
@@ -13823,7 +15120,7 @@
                 <a:ea typeface="Arial" pitchFamily="34" charset="-122"/>
                 <a:cs typeface="Arial" pitchFamily="34" charset="-120"/>
               </a:rPr>
-              <a:t>03 · 20</a:t>
+              <a:t>03 · 21</a:t>
             </a:r>
             <a:endParaRPr lang="en-US" sz="1800" dirty="0"/>
           </a:p>
@@ -14684,8 +15981,8 @@
         </p:nvSpPr>
         <p:spPr>
           <a:xfrm>
-            <a:off x="16432188" y="9510713"/>
-            <a:ext cx="979512" cy="319088"/>
+            <a:off x="16483385" y="9510713"/>
+            <a:ext cx="928315" cy="319088"/>
           </a:xfrm>
           <a:prstGeom prst="rect">
             <a:avLst/>
@@ -14711,7 +16008,7 @@
                 <a:ea typeface="Arial" pitchFamily="34" charset="-122"/>
                 <a:cs typeface="Arial" pitchFamily="34" charset="-120"/>
               </a:rPr>
-              <a:t>04 · 20</a:t>
+              <a:t>04 · 21</a:t>
             </a:r>
             <a:endParaRPr lang="en-US" sz="1800" dirty="0"/>
           </a:p>
@@ -15290,8 +16587,8 @@
         </p:nvSpPr>
         <p:spPr>
           <a:xfrm>
-            <a:off x="16444243" y="9510713"/>
-            <a:ext cx="967457" cy="319088"/>
+            <a:off x="16495440" y="9510713"/>
+            <a:ext cx="916260" cy="319088"/>
           </a:xfrm>
           <a:prstGeom prst="rect">
             <a:avLst/>
@@ -15317,7 +16614,7 @@
                 <a:ea typeface="Arial" pitchFamily="34" charset="-122"/>
                 <a:cs typeface="Arial" pitchFamily="34" charset="-120"/>
               </a:rPr>
-              <a:t>05 · 20</a:t>
+              <a:t>05 · 21</a:t>
             </a:r>
             <a:endParaRPr lang="en-US" sz="1800" dirty="0"/>
           </a:p>
@@ -15890,8 +17187,8 @@
         </p:nvSpPr>
         <p:spPr>
           <a:xfrm>
-            <a:off x="16438066" y="9510713"/>
-            <a:ext cx="973634" cy="319088"/>
+            <a:off x="16489338" y="9510713"/>
+            <a:ext cx="922362" cy="319088"/>
           </a:xfrm>
           <a:prstGeom prst="rect">
             <a:avLst/>
@@ -15917,7 +17214,7 @@
                 <a:ea typeface="Arial" pitchFamily="34" charset="-122"/>
                 <a:cs typeface="Arial" pitchFamily="34" charset="-120"/>
               </a:rPr>
-              <a:t>06 · 20</a:t>
+              <a:t>06 · 21</a:t>
             </a:r>
             <a:endParaRPr lang="en-US" sz="1800" dirty="0"/>
           </a:p>
@@ -16651,8 +17948,8 @@
         </p:nvSpPr>
         <p:spPr>
           <a:xfrm>
-            <a:off x="16454958" y="9510713"/>
-            <a:ext cx="956742" cy="319088"/>
+            <a:off x="16506155" y="9510713"/>
+            <a:ext cx="905545" cy="319088"/>
           </a:xfrm>
           <a:prstGeom prst="rect">
             <a:avLst/>
@@ -16678,7 +17975,7 @@
                 <a:ea typeface="Arial" pitchFamily="34" charset="-122"/>
                 <a:cs typeface="Arial" pitchFamily="34" charset="-120"/>
               </a:rPr>
-              <a:t>07 · 20</a:t>
+              <a:t>07 · 21</a:t>
             </a:r>
             <a:endParaRPr lang="en-US" sz="1800" dirty="0"/>
           </a:p>
@@ -18181,8 +19478,8 @@
         </p:nvSpPr>
         <p:spPr>
           <a:xfrm>
-            <a:off x="16438438" y="9510713"/>
-            <a:ext cx="973262" cy="319088"/>
+            <a:off x="16489635" y="9510713"/>
+            <a:ext cx="922065" cy="319088"/>
           </a:xfrm>
           <a:prstGeom prst="rect">
             <a:avLst/>
@@ -18208,7 +19505,7 @@
                 <a:ea typeface="Arial" pitchFamily="34" charset="-122"/>
                 <a:cs typeface="Arial" pitchFamily="34" charset="-120"/>
               </a:rPr>
-              <a:t>08 · 20</a:t>
+              <a:t>08 · 21</a:t>
             </a:r>
             <a:endParaRPr lang="en-US" sz="1800" dirty="0"/>
           </a:p>
@@ -19159,8 +20456,8 @@
         </p:nvSpPr>
         <p:spPr>
           <a:xfrm>
-            <a:off x="16438066" y="9510713"/>
-            <a:ext cx="973634" cy="319088"/>
+            <a:off x="16489338" y="9510713"/>
+            <a:ext cx="922362" cy="319088"/>
           </a:xfrm>
           <a:prstGeom prst="rect">
             <a:avLst/>
@@ -19186,7 +20483,7 @@
                 <a:ea typeface="Arial" pitchFamily="34" charset="-122"/>
                 <a:cs typeface="Arial" pitchFamily="34" charset="-120"/>
               </a:rPr>
-              <a:t>09 · 20</a:t>
+              <a:t>09 · 21</a:t>
             </a:r>
             <a:endParaRPr lang="en-US" sz="1800" dirty="0"/>
           </a:p>

</xml_diff>

<commit_message>
Slide 7: inject real CARER app screens into phone placeholders
HTML: DOM injection of 4 clean v2 app-screen PNGs (1170x2532 RGB)
into the hatch-pattern placeholder divs, captured at 1920x1080.

Screen mapping (left to right):
  1. A companion that listens → 03_onboarding_first_exchange
  2. Your words, remembered  → 12_inline_memory_card
  3. No scores. No streaks.  → 10_reflection_no_score
  4. Help, one tap away      → 08_crisis_sheet

PPTX: corrected slide-7 screenshot added as full-bleed image (703KB,
covers all 21 placeholder shapes). Fallback method — reliable.

PDF: rebuilt from 21 slide PNGs via PIL (2.4MB, 144dpi, 13.3" wide).

Co-Authored-By: Claude Sonnet 4.6 <noreply@anthropic.com>
</commit_message>
<xml_diff>
--- a/slides/carer-pitch-deck.pptx
+++ b/slides/carer-pitch-deck.pptx
@@ -17981,6 +17981,30 @@
           </a:p>
         </p:txBody>
       </p:sp>
+      <p:pic>
+        <p:nvPicPr>
+          <p:cNvPr id="23" name="Picture 22" descr="deck-07.png"/>
+          <p:cNvPicPr>
+            <a:picLocks noChangeAspect="1"/>
+          </p:cNvPicPr>
+          <p:nvPr/>
+        </p:nvPicPr>
+        <p:blipFill>
+          <a:blip r:embed="rId5"/>
+          <a:stretch>
+            <a:fillRect/>
+          </a:stretch>
+        </p:blipFill>
+        <p:spPr>
+          <a:xfrm>
+            <a:off x="0" y="0"/>
+            <a:ext cx="18288000" cy="10287000"/>
+          </a:xfrm>
+          <a:prstGeom prst="rect">
+            <a:avLst/>
+          </a:prstGeom>
+        </p:spPr>
+      </p:pic>
     </p:spTree>
   </p:cSld>
   <p:clrMapOvr>

</xml_diff>

<commit_message>
Slide 7: fix phone screen injection — clear span children, inject via file:// img
All 4 phones now show real CARER app UI:
- phone1: onboarding first exchange (companion listens)
- phone2: inline memory card (your words, remembered)
- phone3: reflection no-score screen (no scores, no streaks)
- phone4: crisis sheet (help, one tap away)

Fix: previous injection set backgroundImage but left the 'app screen' span child
visible on top. This pass clears innerHTML on each placeholder div first, then
inserts a position:absolute img via file:// URI so it fills the phone frame with
object-fit:cover. All 4 imgs confirmed complete=true, naturalWidth=1170.

Also adds slides/assets/app-screens/ (4 source PNGs, 1170×2532 RGB) and
rebuilds deck-07.png preview, PPTX (replaced slide-7 full-bleed), and PDF (21 pages).

Co-Authored-By: Claude Sonnet 4.6 <noreply@anthropic.com>
</commit_message>
<xml_diff>
--- a/slides/carer-pitch-deck.pptx
+++ b/slides/carer-pitch-deck.pptx
@@ -17983,14 +17983,14 @@
       </p:sp>
       <p:pic>
         <p:nvPicPr>
-          <p:cNvPr id="23" name="Picture 22" descr="deck-07.png"/>
+          <p:cNvPr id="23" name="deck07_screen_injection" descr="deck-07.png"/>
           <p:cNvPicPr>
             <a:picLocks noChangeAspect="1"/>
           </p:cNvPicPr>
           <p:nvPr/>
         </p:nvPicPr>
         <p:blipFill>
-          <a:blip r:embed="rId5"/>
+          <a:blip r:embed="rId6"/>
           <a:stretch>
             <a:fillRect/>
           </a:stretch>

</xml_diff>